<commit_message>
Redesign staircase slide to match reference image (3D steps + capability tracks)
Replace the previous "tall staircase blocks" layout with a clean ascending
4-step diagram inspired by the user-provided reference:
- Each step is a parallelogram tread (light blue / teal / light blue /
  purple) with a small darker rectangle on the right edge giving a 3D
  depth feel. Steps overlap horizontally so each one looks like it sits
  on the previous step's right edge.
- The goal step (都市開発事業の確立) carries a separate
  "2025〜2027年" pennant tag in purple at the top-right.
- Below the staircase, two horizontal capability tracks render as
  blue label boxes plus pentagon arrows:
    運用機能 (shorter) – "不動産運用事業の機能強化"
    開発機能 (longer)  – "回転型不動産事業の機能強化"
- The 開発機能 arrow extends past the rightmost step to convey that
  the development capability is the longer-running track being
  strengthened across all phases.

https://claude.ai/code/session_01C6MNnH3s6RJoyEmWUMTbiA
</commit_message>
<xml_diff>
--- a/統合版_MC2027スタイル_ロードマップ×機能獲得_IR改訂版.pptx
+++ b/統合版_MC2027スタイル_ロードマップ×機能獲得_IR改訂版.pptx
@@ -7795,7 +7795,7 @@
                 </a:solidFill>
                 <a:latin typeface="游ゴシック"/>
               </a:rPr>
-              <a:t>機能獲得の段階的積み上げ（ロードマップ概観）</a:t>
+              <a:t>都市開発事業 ロードマップ概観</a:t>
             </a:r>
           </a:p>
         </p:txBody>
@@ -7865,7 +7865,7 @@
                 </a:solidFill>
                 <a:latin typeface="游ゴシック"/>
               </a:rPr>
-              <a:t>現在 ⇒ 戦略投資フェーズⅠ ⇒ Ⅱ ⇒ 都市開発事業の確立 ― 階段状に機能を獲得</a:t>
+              <a:t>現在 → 戦略投資フェーズⅠ → Ⅱ → 都市開発事業の確立</a:t>
             </a:r>
           </a:p>
         </p:txBody>
@@ -7878,19 +7878,17 @@
         </p:nvSpPr>
         <p:spPr>
           <a:xfrm>
-            <a:off x="6400800" y="868680"/>
-            <a:ext cx="2606040" cy="502920"/>
-          </a:xfrm>
-          <a:prstGeom prst="rect">
-            <a:avLst/>
-          </a:prstGeom>
-          <a:solidFill>
-            <a:srgbClr val="FFFFFF"/>
-          </a:solidFill>
-          <a:ln w="6350">
-            <a:solidFill>
-              <a:srgbClr val="E5E7EB"/>
-            </a:solidFill>
+            <a:off x="7534655" y="1289303"/>
+            <a:ext cx="201168" cy="457200"/>
+          </a:xfrm>
+          <a:prstGeom prst="rect">
+            <a:avLst/>
+          </a:prstGeom>
+          <a:solidFill>
+            <a:srgbClr val="6A689C"/>
+          </a:solidFill>
+          <a:ln>
+            <a:noFill/>
           </a:ln>
           <a:effectLst/>
         </p:spPr>
@@ -7918,60 +7916,24 @@
       </p:sp>
       <p:sp>
         <p:nvSpPr>
-          <p:cNvPr id="8" name="TextBox 7"/>
-          <p:cNvSpPr txBox="1"/>
-          <p:nvPr/>
-        </p:nvSpPr>
-        <p:spPr>
-          <a:xfrm>
-            <a:off x="6492240" y="905256"/>
-            <a:ext cx="2423160" cy="182880"/>
-          </a:xfrm>
-          <a:prstGeom prst="rect">
-            <a:avLst/>
-          </a:prstGeom>
-          <a:noFill/>
-        </p:spPr>
-        <p:txBody>
-          <a:bodyPr wrap="square" lIns="73152" rIns="73152" tIns="36576" bIns="36576" anchor="t">
-            <a:spAutoFit/>
-          </a:bodyPr>
-          <a:lstStyle/>
-          <a:p>
-            <a:pPr algn="l"/>
-            <a:r>
-              <a:rPr sz="800" b="1">
-                <a:solidFill>
-                  <a:srgbClr val="333333"/>
-                </a:solidFill>
-                <a:latin typeface="游ゴシック"/>
-              </a:rPr>
-              <a:t>凡例（機能の三軸）</a:t>
-            </a:r>
-          </a:p>
-        </p:txBody>
-      </p:sp>
-      <p:sp>
-        <p:nvSpPr>
-          <p:cNvPr id="9" name="Rectangle 8"/>
-          <p:cNvSpPr/>
-          <p:nvPr/>
-        </p:nvSpPr>
-        <p:spPr>
-          <a:xfrm>
-            <a:off x="6492240" y="1115568"/>
-            <a:ext cx="777240" cy="201168"/>
-          </a:xfrm>
-          <a:prstGeom prst="rect">
-            <a:avLst/>
-          </a:prstGeom>
-          <a:solidFill>
-            <a:srgbClr val="0B2E5B"/>
+          <p:cNvPr id="8" name="Parallelogram 7"/>
+          <p:cNvSpPr/>
+          <p:nvPr/>
+        </p:nvSpPr>
+        <p:spPr>
+          <a:xfrm>
+            <a:off x="5486399" y="1234439"/>
+            <a:ext cx="2103120" cy="457200"/>
+          </a:xfrm>
+          <a:prstGeom prst="parallelogram">
+            <a:avLst/>
+          </a:prstGeom>
+          <a:solidFill>
+            <a:srgbClr val="A9A7D2"/>
           </a:solidFill>
           <a:ln>
             <a:noFill/>
           </a:ln>
-          <a:effectLst/>
         </p:spPr>
         <p:style>
           <a:lnRef idx="1">
@@ -7992,63 +7954,39 @@
           <a:lstStyle/>
           <a:p>
             <a:pPr algn="ctr"/>
-          </a:p>
-        </p:txBody>
-      </p:sp>
-      <p:sp>
-        <p:nvSpPr>
-          <p:cNvPr id="10" name="TextBox 9"/>
-          <p:cNvSpPr txBox="1"/>
-          <p:nvPr/>
-        </p:nvSpPr>
-        <p:spPr>
-          <a:xfrm>
-            <a:off x="6492240" y="1115568"/>
-            <a:ext cx="777240" cy="201168"/>
-          </a:xfrm>
-          <a:prstGeom prst="rect">
-            <a:avLst/>
-          </a:prstGeom>
-          <a:noFill/>
-        </p:spPr>
-        <p:txBody>
-          <a:bodyPr wrap="square" lIns="73152" rIns="73152" tIns="36576" bIns="36576" anchor="ctr">
-            <a:spAutoFit/>
-          </a:bodyPr>
-          <a:lstStyle/>
-          <a:p>
-            <a:pPr algn="ctr"/>
-            <a:r>
-              <a:rPr sz="800" b="1">
+            <a:r>
+              <a:rPr sz="1200" b="1">
                 <a:solidFill>
                   <a:srgbClr val="FFFFFF"/>
                 </a:solidFill>
                 <a:latin typeface="游ゴシック"/>
               </a:rPr>
-              <a:t>D 開発力</a:t>
-            </a:r>
-          </a:p>
-        </p:txBody>
-      </p:sp>
-      <p:sp>
-        <p:nvSpPr>
-          <p:cNvPr id="11" name="Rectangle 10"/>
-          <p:cNvSpPr/>
-          <p:nvPr/>
-        </p:nvSpPr>
-        <p:spPr>
-          <a:xfrm>
-            <a:off x="7287768" y="1115568"/>
-            <a:ext cx="777240" cy="201168"/>
-          </a:xfrm>
-          <a:prstGeom prst="rect">
-            <a:avLst/>
-          </a:prstGeom>
-          <a:solidFill>
-            <a:srgbClr val="1F4E8F"/>
-          </a:solidFill>
-          <a:ln>
-            <a:noFill/>
+              <a:t>都市開発事業の確立</a:t>
+            </a:r>
+          </a:p>
+        </p:txBody>
+      </p:sp>
+      <p:sp>
+        <p:nvSpPr>
+          <p:cNvPr id="9" name="Rectangle 8"/>
+          <p:cNvSpPr/>
+          <p:nvPr/>
+        </p:nvSpPr>
+        <p:spPr>
+          <a:xfrm>
+            <a:off x="7315199" y="731519"/>
+            <a:ext cx="1691640" cy="365760"/>
+          </a:xfrm>
+          <a:prstGeom prst="rect">
+            <a:avLst/>
+          </a:prstGeom>
+          <a:solidFill>
+            <a:srgbClr val="FFFFFF"/>
+          </a:solidFill>
+          <a:ln w="19050">
+            <a:solidFill>
+              <a:srgbClr val="602E9A"/>
+            </a:solidFill>
           </a:ln>
           <a:effectLst/>
         </p:spPr>
@@ -8076,14 +8014,14 @@
       </p:sp>
       <p:sp>
         <p:nvSpPr>
-          <p:cNvPr id="12" name="TextBox 11"/>
+          <p:cNvPr id="10" name="TextBox 9"/>
           <p:cNvSpPr txBox="1"/>
           <p:nvPr/>
         </p:nvSpPr>
         <p:spPr>
           <a:xfrm>
-            <a:off x="7287768" y="1115568"/>
-            <a:ext cx="777240" cy="201168"/>
+            <a:off x="7315199" y="731519"/>
+            <a:ext cx="1691640" cy="365760"/>
           </a:xfrm>
           <a:prstGeom prst="rect">
             <a:avLst/>
@@ -8098,33 +8036,33 @@
           <a:p>
             <a:pPr algn="ctr"/>
             <a:r>
-              <a:rPr sz="800" b="1">
-                <a:solidFill>
-                  <a:srgbClr val="FFFFFF"/>
+              <a:rPr sz="1300" b="1">
+                <a:solidFill>
+                  <a:srgbClr val="602E9A"/>
                 </a:solidFill>
                 <a:latin typeface="游ゴシック"/>
               </a:rPr>
-              <a:t>A 運用力</a:t>
-            </a:r>
-          </a:p>
-        </p:txBody>
-      </p:sp>
-      <p:sp>
-        <p:nvSpPr>
-          <p:cNvPr id="13" name="Rectangle 12"/>
-          <p:cNvSpPr/>
-          <p:nvPr/>
-        </p:nvSpPr>
-        <p:spPr>
-          <a:xfrm>
-            <a:off x="8083296" y="1115568"/>
-            <a:ext cx="777240" cy="201168"/>
-          </a:xfrm>
-          <a:prstGeom prst="rect">
-            <a:avLst/>
-          </a:prstGeom>
-          <a:solidFill>
-            <a:srgbClr val="007A87"/>
+              <a:t>2025〜2027年</a:t>
+            </a:r>
+          </a:p>
+        </p:txBody>
+      </p:sp>
+      <p:sp>
+        <p:nvSpPr>
+          <p:cNvPr id="11" name="Rectangle 10"/>
+          <p:cNvSpPr/>
+          <p:nvPr/>
+        </p:nvSpPr>
+        <p:spPr>
+          <a:xfrm>
+            <a:off x="5797296" y="1883663"/>
+            <a:ext cx="201168" cy="457200"/>
+          </a:xfrm>
+          <a:prstGeom prst="rect">
+            <a:avLst/>
+          </a:prstGeom>
+          <a:solidFill>
+            <a:srgbClr val="4A7CA8"/>
           </a:solidFill>
           <a:ln>
             <a:noFill/>
@@ -8155,60 +8093,24 @@
       </p:sp>
       <p:sp>
         <p:nvSpPr>
-          <p:cNvPr id="14" name="TextBox 13"/>
-          <p:cNvSpPr txBox="1"/>
-          <p:nvPr/>
-        </p:nvSpPr>
-        <p:spPr>
-          <a:xfrm>
-            <a:off x="8083296" y="1115568"/>
-            <a:ext cx="777240" cy="201168"/>
-          </a:xfrm>
-          <a:prstGeom prst="rect">
-            <a:avLst/>
-          </a:prstGeom>
-          <a:noFill/>
-        </p:spPr>
-        <p:txBody>
-          <a:bodyPr wrap="square" lIns="73152" rIns="73152" tIns="36576" bIns="36576" anchor="ctr">
-            <a:spAutoFit/>
-          </a:bodyPr>
-          <a:lstStyle/>
-          <a:p>
-            <a:pPr algn="ctr"/>
-            <a:r>
-              <a:rPr sz="800" b="1">
-                <a:solidFill>
-                  <a:srgbClr val="FFFFFF"/>
-                </a:solidFill>
-                <a:latin typeface="游ゴシック"/>
-              </a:rPr>
-              <a:t>O 運営力</a:t>
-            </a:r>
-          </a:p>
-        </p:txBody>
-      </p:sp>
-      <p:sp>
-        <p:nvSpPr>
-          <p:cNvPr id="15" name="Rectangle 14"/>
-          <p:cNvSpPr/>
-          <p:nvPr/>
-        </p:nvSpPr>
-        <p:spPr>
-          <a:xfrm>
-            <a:off x="182880" y="3840480"/>
-            <a:ext cx="2057400" cy="822959"/>
-          </a:xfrm>
-          <a:prstGeom prst="rect">
-            <a:avLst/>
-          </a:prstGeom>
-          <a:solidFill>
-            <a:srgbClr val="666A73"/>
+          <p:cNvPr id="12" name="Parallelogram 11"/>
+          <p:cNvSpPr/>
+          <p:nvPr/>
+        </p:nvSpPr>
+        <p:spPr>
+          <a:xfrm>
+            <a:off x="3749039" y="1828799"/>
+            <a:ext cx="2103120" cy="457200"/>
+          </a:xfrm>
+          <a:prstGeom prst="parallelogram">
+            <a:avLst/>
+          </a:prstGeom>
+          <a:solidFill>
+            <a:srgbClr val="A9CCE0"/>
           </a:solidFill>
           <a:ln>
             <a:noFill/>
           </a:ln>
-          <a:effectLst/>
         </p:spPr>
         <p:style>
           <a:lnRef idx="1">
@@ -8229,130 +8131,34 @@
           <a:lstStyle/>
           <a:p>
             <a:pPr algn="ctr"/>
-          </a:p>
-        </p:txBody>
-      </p:sp>
-      <p:sp>
-        <p:nvSpPr>
-          <p:cNvPr id="16" name="TextBox 15"/>
-          <p:cNvSpPr txBox="1"/>
-          <p:nvPr/>
-        </p:nvSpPr>
-        <p:spPr>
-          <a:xfrm>
-            <a:off x="256032" y="3895344"/>
-            <a:ext cx="1911095" cy="256032"/>
-          </a:xfrm>
-          <a:prstGeom prst="rect">
-            <a:avLst/>
-          </a:prstGeom>
-          <a:noFill/>
-        </p:spPr>
-        <p:txBody>
-          <a:bodyPr wrap="square" lIns="73152" rIns="73152" tIns="36576" bIns="36576" anchor="t">
-            <a:spAutoFit/>
-          </a:bodyPr>
-          <a:lstStyle/>
-          <a:p>
-            <a:pPr algn="l"/>
-            <a:r>
-              <a:rPr sz="1100" b="1">
+            <a:r>
+              <a:rPr sz="1200" b="1">
                 <a:solidFill>
                   <a:srgbClr val="FFFFFF"/>
                 </a:solidFill>
                 <a:latin typeface="游ゴシック"/>
               </a:rPr>
-              <a:t>① 現在 (As is)</a:t>
-            </a:r>
-          </a:p>
-        </p:txBody>
-      </p:sp>
-      <p:sp>
-        <p:nvSpPr>
-          <p:cNvPr id="17" name="TextBox 16"/>
-          <p:cNvSpPr txBox="1"/>
-          <p:nvPr/>
-        </p:nvSpPr>
-        <p:spPr>
-          <a:xfrm>
-            <a:off x="1280160" y="3895344"/>
-            <a:ext cx="868680" cy="256032"/>
-          </a:xfrm>
-          <a:prstGeom prst="rect">
-            <a:avLst/>
-          </a:prstGeom>
-          <a:noFill/>
-        </p:spPr>
-        <p:txBody>
-          <a:bodyPr wrap="square" lIns="73152" rIns="73152" tIns="36576" bIns="36576" anchor="t">
-            <a:spAutoFit/>
-          </a:bodyPr>
-          <a:lstStyle/>
-          <a:p>
-            <a:pPr algn="r"/>
-            <a:r>
-              <a:rPr sz="900" b="1">
-                <a:solidFill>
-                  <a:srgbClr val="FFFFFF"/>
-                </a:solidFill>
-                <a:latin typeface="游ゴシック"/>
-              </a:rPr>
-              <a:t>累計 0/10</a:t>
-            </a:r>
-          </a:p>
-        </p:txBody>
-      </p:sp>
-      <p:sp>
-        <p:nvSpPr>
-          <p:cNvPr id="18" name="TextBox 17"/>
-          <p:cNvSpPr txBox="1"/>
-          <p:nvPr/>
-        </p:nvSpPr>
-        <p:spPr>
-          <a:xfrm>
-            <a:off x="256032" y="4389120"/>
-            <a:ext cx="1911095" cy="228600"/>
-          </a:xfrm>
-          <a:prstGeom prst="rect">
-            <a:avLst/>
-          </a:prstGeom>
-          <a:noFill/>
-        </p:spPr>
-        <p:txBody>
-          <a:bodyPr wrap="square" lIns="73152" rIns="73152" tIns="36576" bIns="36576" anchor="ctr">
-            <a:spAutoFit/>
-          </a:bodyPr>
-          <a:lstStyle/>
-          <a:p>
-            <a:pPr algn="l"/>
-            <a:r>
-              <a:rPr sz="900" b="1">
-                <a:solidFill>
-                  <a:srgbClr val="FFFFFF"/>
-                </a:solidFill>
-                <a:latin typeface="游ゴシック"/>
-              </a:rPr>
-              <a:t>出発点：既獲得の機能のみ</a:t>
-            </a:r>
-          </a:p>
-        </p:txBody>
-      </p:sp>
-      <p:sp>
-        <p:nvSpPr>
-          <p:cNvPr id="19" name="Rectangle 18"/>
-          <p:cNvSpPr/>
-          <p:nvPr/>
-        </p:nvSpPr>
-        <p:spPr>
-          <a:xfrm>
-            <a:off x="2295144" y="3017520"/>
-            <a:ext cx="2057400" cy="1645919"/>
-          </a:xfrm>
-          <a:prstGeom prst="rect">
-            <a:avLst/>
-          </a:prstGeom>
-          <a:solidFill>
-            <a:srgbClr val="1F4E8F"/>
+              <a:t>戦略投資フェーズⅡ</a:t>
+            </a:r>
+          </a:p>
+        </p:txBody>
+      </p:sp>
+      <p:sp>
+        <p:nvSpPr>
+          <p:cNvPr id="13" name="Rectangle 12"/>
+          <p:cNvSpPr/>
+          <p:nvPr/>
+        </p:nvSpPr>
+        <p:spPr>
+          <a:xfrm>
+            <a:off x="4059936" y="2478024"/>
+            <a:ext cx="201168" cy="457200"/>
+          </a:xfrm>
+          <a:prstGeom prst="rect">
+            <a:avLst/>
+          </a:prstGeom>
+          <a:solidFill>
+            <a:srgbClr val="2D837A"/>
           </a:solidFill>
           <a:ln>
             <a:noFill/>
@@ -8383,278 +8189,24 @@
       </p:sp>
       <p:sp>
         <p:nvSpPr>
-          <p:cNvPr id="20" name="TextBox 19"/>
-          <p:cNvSpPr txBox="1"/>
-          <p:nvPr/>
-        </p:nvSpPr>
-        <p:spPr>
-          <a:xfrm>
-            <a:off x="2368296" y="3072384"/>
-            <a:ext cx="1911095" cy="256032"/>
-          </a:xfrm>
-          <a:prstGeom prst="rect">
-            <a:avLst/>
-          </a:prstGeom>
-          <a:noFill/>
-        </p:spPr>
-        <p:txBody>
-          <a:bodyPr wrap="square" lIns="73152" rIns="73152" tIns="36576" bIns="36576" anchor="t">
-            <a:spAutoFit/>
-          </a:bodyPr>
-          <a:lstStyle/>
-          <a:p>
-            <a:pPr algn="l"/>
-            <a:r>
-              <a:rPr sz="1100" b="1">
-                <a:solidFill>
-                  <a:srgbClr val="FFFFFF"/>
-                </a:solidFill>
-                <a:latin typeface="游ゴシック"/>
-              </a:rPr>
-              <a:t>② 戦略投資フェーズⅠ</a:t>
-            </a:r>
-          </a:p>
-        </p:txBody>
-      </p:sp>
-      <p:sp>
-        <p:nvSpPr>
-          <p:cNvPr id="21" name="TextBox 20"/>
-          <p:cNvSpPr txBox="1"/>
-          <p:nvPr/>
-        </p:nvSpPr>
-        <p:spPr>
-          <a:xfrm>
-            <a:off x="3392424" y="3072384"/>
-            <a:ext cx="868680" cy="256032"/>
-          </a:xfrm>
-          <a:prstGeom prst="rect">
-            <a:avLst/>
-          </a:prstGeom>
-          <a:noFill/>
-        </p:spPr>
-        <p:txBody>
-          <a:bodyPr wrap="square" lIns="73152" rIns="73152" tIns="36576" bIns="36576" anchor="t">
-            <a:spAutoFit/>
-          </a:bodyPr>
-          <a:lstStyle/>
-          <a:p>
-            <a:pPr algn="r"/>
-            <a:r>
-              <a:rPr sz="900" b="1">
-                <a:solidFill>
-                  <a:srgbClr val="FFFFFF"/>
-                </a:solidFill>
-                <a:latin typeface="游ゴシック"/>
-              </a:rPr>
-              <a:t>累計 5/10</a:t>
-            </a:r>
-          </a:p>
-        </p:txBody>
-      </p:sp>
-      <p:sp>
-        <p:nvSpPr>
-          <p:cNvPr id="22" name="TextBox 21"/>
-          <p:cNvSpPr txBox="1"/>
-          <p:nvPr/>
-        </p:nvSpPr>
-        <p:spPr>
-          <a:xfrm>
-            <a:off x="2368296" y="3401568"/>
-            <a:ext cx="1911095" cy="969263"/>
-          </a:xfrm>
-          <a:prstGeom prst="rect">
-            <a:avLst/>
-          </a:prstGeom>
-          <a:noFill/>
-        </p:spPr>
-        <p:txBody>
-          <a:bodyPr wrap="square">
-            <a:spAutoFit/>
-          </a:bodyPr>
-          <a:lstStyle/>
-          <a:p>
-            <a:pPr>
-              <a:spcBef>
-                <a:spcPts val="200"/>
-              </a:spcBef>
-            </a:pPr>
-            <a:r>
-              <a:rPr sz="800" b="1">
-                <a:solidFill>
-                  <a:srgbClr val="FFFFFF"/>
-                </a:solidFill>
-                <a:latin typeface="游ゴシック"/>
-              </a:rPr>
-              <a:t>[D] </a:t>
-            </a:r>
-            <a:r>
-              <a:rPr sz="900">
-                <a:solidFill>
-                  <a:srgbClr val="FFFFFF"/>
-                </a:solidFill>
-                <a:latin typeface="游ゴシック"/>
-              </a:rPr>
-              <a:t>多様なアセットクラスへの対応力</a:t>
-            </a:r>
-          </a:p>
-          <a:p>
-            <a:pPr>
-              <a:spcBef>
-                <a:spcPts val="200"/>
-              </a:spcBef>
-            </a:pPr>
-            <a:r>
-              <a:rPr sz="800" b="1">
-                <a:solidFill>
-                  <a:srgbClr val="FFFFFF"/>
-                </a:solidFill>
-                <a:latin typeface="游ゴシック"/>
-              </a:rPr>
-              <a:t>[D] </a:t>
-            </a:r>
-            <a:r>
-              <a:rPr sz="900">
-                <a:solidFill>
-                  <a:srgbClr val="FFFFFF"/>
-                </a:solidFill>
-                <a:latin typeface="游ゴシック"/>
-              </a:rPr>
-              <a:t>産業・商業複合型 企画・ソーシング力</a:t>
-            </a:r>
-          </a:p>
-          <a:p>
-            <a:pPr>
-              <a:spcBef>
-                <a:spcPts val="200"/>
-              </a:spcBef>
-            </a:pPr>
-            <a:r>
-              <a:rPr sz="800" b="1">
-                <a:solidFill>
-                  <a:srgbClr val="FFFFFF"/>
-                </a:solidFill>
-                <a:latin typeface="游ゴシック"/>
-              </a:rPr>
-              <a:t>[A] </a:t>
-            </a:r>
-            <a:r>
-              <a:rPr sz="900">
-                <a:solidFill>
-                  <a:srgbClr val="FFFFFF"/>
-                </a:solidFill>
-                <a:latin typeface="游ゴシック"/>
-              </a:rPr>
-              <a:t>投資家基盤の拡充・パイプライン構築</a:t>
-            </a:r>
-          </a:p>
-          <a:p>
-            <a:pPr>
-              <a:spcBef>
-                <a:spcPts val="200"/>
-              </a:spcBef>
-            </a:pPr>
-            <a:r>
-              <a:rPr sz="800" b="1">
-                <a:solidFill>
-                  <a:srgbClr val="FFFFFF"/>
-                </a:solidFill>
-                <a:latin typeface="游ゴシック"/>
-              </a:rPr>
-              <a:t>[A] </a:t>
-            </a:r>
-            <a:r>
-              <a:rPr sz="900">
-                <a:solidFill>
-                  <a:srgbClr val="FFFFFF"/>
-                </a:solidFill>
-                <a:latin typeface="游ゴシック"/>
-              </a:rPr>
-              <a:t>ファンド組成・AM体制構築</a:t>
-            </a:r>
-          </a:p>
-          <a:p>
-            <a:pPr>
-              <a:spcBef>
-                <a:spcPts val="200"/>
-              </a:spcBef>
-            </a:pPr>
-            <a:r>
-              <a:rPr sz="800" b="1">
-                <a:solidFill>
-                  <a:srgbClr val="FFFFFF"/>
-                </a:solidFill>
-                <a:latin typeface="游ゴシック"/>
-              </a:rPr>
-              <a:t>[O] </a:t>
-            </a:r>
-            <a:r>
-              <a:rPr sz="900">
-                <a:solidFill>
-                  <a:srgbClr val="FFFFFF"/>
-                </a:solidFill>
-                <a:latin typeface="游ゴシック"/>
-              </a:rPr>
-              <a:t>NOI拡大・バリューアップ機能</a:t>
-            </a:r>
-          </a:p>
-        </p:txBody>
-      </p:sp>
-      <p:sp>
-        <p:nvSpPr>
-          <p:cNvPr id="23" name="TextBox 22"/>
-          <p:cNvSpPr txBox="1"/>
-          <p:nvPr/>
-        </p:nvSpPr>
-        <p:spPr>
-          <a:xfrm>
-            <a:off x="2368296" y="4389120"/>
-            <a:ext cx="1911095" cy="228600"/>
-          </a:xfrm>
-          <a:prstGeom prst="rect">
-            <a:avLst/>
-          </a:prstGeom>
-          <a:noFill/>
-        </p:spPr>
-        <p:txBody>
-          <a:bodyPr wrap="square" lIns="73152" rIns="73152" tIns="36576" bIns="36576" anchor="ctr">
-            <a:spAutoFit/>
-          </a:bodyPr>
-          <a:lstStyle/>
-          <a:p>
-            <a:pPr algn="l"/>
-            <a:r>
-              <a:rPr sz="900" b="1">
-                <a:solidFill>
-                  <a:srgbClr val="FFFFFF"/>
-                </a:solidFill>
-                <a:latin typeface="游ゴシック"/>
-              </a:rPr>
-              <a:t>+ 5機能（基盤構築）</a:t>
-            </a:r>
-          </a:p>
-        </p:txBody>
-      </p:sp>
-      <p:sp>
-        <p:nvSpPr>
-          <p:cNvPr id="24" name="Rectangle 23"/>
-          <p:cNvSpPr/>
-          <p:nvPr/>
-        </p:nvSpPr>
-        <p:spPr>
-          <a:xfrm>
-            <a:off x="4407408" y="2194560"/>
-            <a:ext cx="2057400" cy="2468879"/>
-          </a:xfrm>
-          <a:prstGeom prst="rect">
-            <a:avLst/>
-          </a:prstGeom>
-          <a:solidFill>
-            <a:srgbClr val="007A87"/>
+          <p:cNvPr id="14" name="Parallelogram 13"/>
+          <p:cNvSpPr/>
+          <p:nvPr/>
+        </p:nvSpPr>
+        <p:spPr>
+          <a:xfrm>
+            <a:off x="2011679" y="2423160"/>
+            <a:ext cx="2103120" cy="457200"/>
+          </a:xfrm>
+          <a:prstGeom prst="parallelogram">
+            <a:avLst/>
+          </a:prstGeom>
+          <a:solidFill>
+            <a:srgbClr val="4FB3A8"/>
           </a:solidFill>
           <a:ln>
             <a:noFill/>
           </a:ln>
-          <a:effectLst/>
         </p:spPr>
         <p:style>
           <a:lnRef idx="1">
@@ -8675,253 +8227,34 @@
           <a:lstStyle/>
           <a:p>
             <a:pPr algn="ctr"/>
-          </a:p>
-        </p:txBody>
-      </p:sp>
-      <p:sp>
-        <p:nvSpPr>
-          <p:cNvPr id="25" name="TextBox 24"/>
-          <p:cNvSpPr txBox="1"/>
-          <p:nvPr/>
-        </p:nvSpPr>
-        <p:spPr>
-          <a:xfrm>
-            <a:off x="4480560" y="2249424"/>
-            <a:ext cx="1911095" cy="256032"/>
-          </a:xfrm>
-          <a:prstGeom prst="rect">
-            <a:avLst/>
-          </a:prstGeom>
-          <a:noFill/>
-        </p:spPr>
-        <p:txBody>
-          <a:bodyPr wrap="square" lIns="73152" rIns="73152" tIns="36576" bIns="36576" anchor="t">
-            <a:spAutoFit/>
-          </a:bodyPr>
-          <a:lstStyle/>
-          <a:p>
-            <a:pPr algn="l"/>
-            <a:r>
-              <a:rPr sz="1100" b="1">
+            <a:r>
+              <a:rPr sz="1200" b="1">
                 <a:solidFill>
                   <a:srgbClr val="FFFFFF"/>
                 </a:solidFill>
                 <a:latin typeface="游ゴシック"/>
               </a:rPr>
-              <a:t>③ 戦略投資フェーズⅡ</a:t>
-            </a:r>
-          </a:p>
-        </p:txBody>
-      </p:sp>
-      <p:sp>
-        <p:nvSpPr>
-          <p:cNvPr id="26" name="TextBox 25"/>
-          <p:cNvSpPr txBox="1"/>
-          <p:nvPr/>
-        </p:nvSpPr>
-        <p:spPr>
-          <a:xfrm>
-            <a:off x="5504688" y="2249424"/>
-            <a:ext cx="868680" cy="256032"/>
-          </a:xfrm>
-          <a:prstGeom prst="rect">
-            <a:avLst/>
-          </a:prstGeom>
-          <a:noFill/>
-        </p:spPr>
-        <p:txBody>
-          <a:bodyPr wrap="square" lIns="73152" rIns="73152" tIns="36576" bIns="36576" anchor="t">
-            <a:spAutoFit/>
-          </a:bodyPr>
-          <a:lstStyle/>
-          <a:p>
-            <a:pPr algn="r"/>
-            <a:r>
-              <a:rPr sz="900" b="1">
-                <a:solidFill>
-                  <a:srgbClr val="FFFFFF"/>
-                </a:solidFill>
-                <a:latin typeface="游ゴシック"/>
-              </a:rPr>
-              <a:t>累計 9/10</a:t>
-            </a:r>
-          </a:p>
-        </p:txBody>
-      </p:sp>
-      <p:sp>
-        <p:nvSpPr>
-          <p:cNvPr id="27" name="TextBox 26"/>
-          <p:cNvSpPr txBox="1"/>
-          <p:nvPr/>
-        </p:nvSpPr>
-        <p:spPr>
-          <a:xfrm>
-            <a:off x="4480560" y="2578608"/>
-            <a:ext cx="1911095" cy="1792223"/>
-          </a:xfrm>
-          <a:prstGeom prst="rect">
-            <a:avLst/>
-          </a:prstGeom>
-          <a:noFill/>
-        </p:spPr>
-        <p:txBody>
-          <a:bodyPr wrap="square">
-            <a:spAutoFit/>
-          </a:bodyPr>
-          <a:lstStyle/>
-          <a:p>
-            <a:pPr>
-              <a:spcBef>
-                <a:spcPts val="200"/>
-              </a:spcBef>
-            </a:pPr>
-            <a:r>
-              <a:rPr sz="800" b="1">
-                <a:solidFill>
-                  <a:srgbClr val="FFFFFF"/>
-                </a:solidFill>
-                <a:latin typeface="游ゴシック"/>
-              </a:rPr>
-              <a:t>[D] </a:t>
-            </a:r>
-            <a:r>
-              <a:rPr sz="900">
-                <a:solidFill>
-                  <a:srgbClr val="FFFFFF"/>
-                </a:solidFill>
-                <a:latin typeface="游ゴシック"/>
-              </a:rPr>
-              <a:t>バリューアップ型開発機能</a:t>
-            </a:r>
-          </a:p>
-          <a:p>
-            <a:pPr>
-              <a:spcBef>
-                <a:spcPts val="200"/>
-              </a:spcBef>
-            </a:pPr>
-            <a:r>
-              <a:rPr sz="800" b="1">
-                <a:solidFill>
-                  <a:srgbClr val="FFFFFF"/>
-                </a:solidFill>
-                <a:latin typeface="游ゴシック"/>
-              </a:rPr>
-              <a:t>[D] </a:t>
-            </a:r>
-            <a:r>
-              <a:rPr sz="900">
-                <a:solidFill>
-                  <a:srgbClr val="FFFFFF"/>
-                </a:solidFill>
-                <a:latin typeface="游ゴシック"/>
-              </a:rPr>
-              <a:t>開発〜Exit の収益サイクル確立</a:t>
-            </a:r>
-          </a:p>
-          <a:p>
-            <a:pPr>
-              <a:spcBef>
-                <a:spcPts val="200"/>
-              </a:spcBef>
-            </a:pPr>
-            <a:r>
-              <a:rPr sz="800" b="1">
-                <a:solidFill>
-                  <a:srgbClr val="FFFFFF"/>
-                </a:solidFill>
-                <a:latin typeface="游ゴシック"/>
-              </a:rPr>
-              <a:t>[A] </a:t>
-            </a:r>
-            <a:r>
-              <a:rPr sz="900">
-                <a:solidFill>
-                  <a:srgbClr val="FFFFFF"/>
-                </a:solidFill>
-                <a:latin typeface="游ゴシック"/>
-              </a:rPr>
-              <a:t>AUM拡大・投資判断力の体系化</a:t>
-            </a:r>
-          </a:p>
-          <a:p>
-            <a:pPr>
-              <a:spcBef>
-                <a:spcPts val="200"/>
-              </a:spcBef>
-            </a:pPr>
-            <a:r>
-              <a:rPr sz="800" b="1">
-                <a:solidFill>
-                  <a:srgbClr val="FFFFFF"/>
-                </a:solidFill>
-                <a:latin typeface="游ゴシック"/>
-              </a:rPr>
-              <a:t>[O] </a:t>
-            </a:r>
-            <a:r>
-              <a:rPr sz="900">
-                <a:solidFill>
-                  <a:srgbClr val="FFFFFF"/>
-                </a:solidFill>
-                <a:latin typeface="游ゴシック"/>
-              </a:rPr>
-              <a:t>関連事業の再編・都市運営PF確立</a:t>
-            </a:r>
-          </a:p>
-        </p:txBody>
-      </p:sp>
-      <p:sp>
-        <p:nvSpPr>
-          <p:cNvPr id="28" name="TextBox 27"/>
-          <p:cNvSpPr txBox="1"/>
-          <p:nvPr/>
-        </p:nvSpPr>
-        <p:spPr>
-          <a:xfrm>
-            <a:off x="4480560" y="4389120"/>
-            <a:ext cx="1911095" cy="228600"/>
-          </a:xfrm>
-          <a:prstGeom prst="rect">
-            <a:avLst/>
-          </a:prstGeom>
-          <a:noFill/>
-        </p:spPr>
-        <p:txBody>
-          <a:bodyPr wrap="square" lIns="73152" rIns="73152" tIns="36576" bIns="36576" anchor="ctr">
-            <a:spAutoFit/>
-          </a:bodyPr>
-          <a:lstStyle/>
-          <a:p>
-            <a:pPr algn="l"/>
-            <a:r>
-              <a:rPr sz="900" b="1">
-                <a:solidFill>
-                  <a:srgbClr val="FFFFFF"/>
-                </a:solidFill>
-                <a:latin typeface="游ゴシック"/>
-              </a:rPr>
-              <a:t>+ 4機能（事業拡大）</a:t>
-            </a:r>
-          </a:p>
-        </p:txBody>
-      </p:sp>
-      <p:sp>
-        <p:nvSpPr>
-          <p:cNvPr id="29" name="Rectangle 28"/>
-          <p:cNvSpPr/>
-          <p:nvPr/>
-        </p:nvSpPr>
-        <p:spPr>
-          <a:xfrm>
-            <a:off x="6519672" y="1371600"/>
-            <a:ext cx="2057400" cy="3291839"/>
-          </a:xfrm>
-          <a:prstGeom prst="rect">
-            <a:avLst/>
-          </a:prstGeom>
-          <a:solidFill>
-            <a:srgbClr val="0B2E5B"/>
+              <a:t>戦略投資フェーズⅠ</a:t>
+            </a:r>
+          </a:p>
+        </p:txBody>
+      </p:sp>
+      <p:sp>
+        <p:nvSpPr>
+          <p:cNvPr id="15" name="Rectangle 14"/>
+          <p:cNvSpPr/>
+          <p:nvPr/>
+        </p:nvSpPr>
+        <p:spPr>
+          <a:xfrm>
+            <a:off x="2322575" y="3072384"/>
+            <a:ext cx="201168" cy="457200"/>
+          </a:xfrm>
+          <a:prstGeom prst="rect">
+            <a:avLst/>
+          </a:prstGeom>
+          <a:solidFill>
+            <a:srgbClr val="4A7CA8"/>
           </a:solidFill>
           <a:ln>
             <a:noFill/>
@@ -8952,14 +8285,332 @@
       </p:sp>
       <p:sp>
         <p:nvSpPr>
-          <p:cNvPr id="30" name="TextBox 29"/>
+          <p:cNvPr id="16" name="Parallelogram 15"/>
+          <p:cNvSpPr/>
+          <p:nvPr/>
+        </p:nvSpPr>
+        <p:spPr>
+          <a:xfrm>
+            <a:off x="274320" y="3017520"/>
+            <a:ext cx="2103120" cy="457200"/>
+          </a:xfrm>
+          <a:prstGeom prst="parallelogram">
+            <a:avLst/>
+          </a:prstGeom>
+          <a:solidFill>
+            <a:srgbClr val="A9CCE0"/>
+          </a:solidFill>
+          <a:ln>
+            <a:noFill/>
+          </a:ln>
+        </p:spPr>
+        <p:style>
+          <a:lnRef idx="1">
+            <a:schemeClr val="accent1"/>
+          </a:lnRef>
+          <a:fillRef idx="3">
+            <a:schemeClr val="accent1"/>
+          </a:fillRef>
+          <a:effectRef idx="2">
+            <a:schemeClr val="accent1"/>
+          </a:effectRef>
+          <a:fontRef idx="minor">
+            <a:schemeClr val="lt1"/>
+          </a:fontRef>
+        </p:style>
+        <p:txBody>
+          <a:bodyPr rtlCol="0" anchor="ctr"/>
+          <a:lstStyle/>
+          <a:p>
+            <a:pPr algn="ctr"/>
+            <a:r>
+              <a:rPr sz="1200" b="1">
+                <a:solidFill>
+                  <a:srgbClr val="FFFFFF"/>
+                </a:solidFill>
+                <a:latin typeface="游ゴシック"/>
+              </a:rPr>
+              <a:t>現在 (As is)</a:t>
+            </a:r>
+          </a:p>
+        </p:txBody>
+      </p:sp>
+      <p:sp>
+        <p:nvSpPr>
+          <p:cNvPr id="17" name="Rectangle 16"/>
+          <p:cNvSpPr/>
+          <p:nvPr/>
+        </p:nvSpPr>
+        <p:spPr>
+          <a:xfrm>
+            <a:off x="274320" y="3840480"/>
+            <a:ext cx="1097280" cy="384048"/>
+          </a:xfrm>
+          <a:prstGeom prst="rect">
+            <a:avLst/>
+          </a:prstGeom>
+          <a:solidFill>
+            <a:srgbClr val="4F81BD"/>
+          </a:solidFill>
+          <a:ln>
+            <a:noFill/>
+          </a:ln>
+          <a:effectLst/>
+        </p:spPr>
+        <p:style>
+          <a:lnRef idx="1">
+            <a:schemeClr val="accent1"/>
+          </a:lnRef>
+          <a:fillRef idx="3">
+            <a:schemeClr val="accent1"/>
+          </a:fillRef>
+          <a:effectRef idx="2">
+            <a:schemeClr val="accent1"/>
+          </a:effectRef>
+          <a:fontRef idx="minor">
+            <a:schemeClr val="lt1"/>
+          </a:fontRef>
+        </p:style>
+        <p:txBody>
+          <a:bodyPr rtlCol="0" anchor="ctr"/>
+          <a:lstStyle/>
+          <a:p>
+            <a:pPr algn="ctr"/>
+          </a:p>
+        </p:txBody>
+      </p:sp>
+      <p:sp>
+        <p:nvSpPr>
+          <p:cNvPr id="18" name="TextBox 17"/>
           <p:cNvSpPr txBox="1"/>
           <p:nvPr/>
         </p:nvSpPr>
         <p:spPr>
           <a:xfrm>
-            <a:off x="6592824" y="1426464"/>
-            <a:ext cx="1911095" cy="256032"/>
+            <a:off x="274320" y="3840480"/>
+            <a:ext cx="1097280" cy="384048"/>
+          </a:xfrm>
+          <a:prstGeom prst="rect">
+            <a:avLst/>
+          </a:prstGeom>
+          <a:noFill/>
+        </p:spPr>
+        <p:txBody>
+          <a:bodyPr wrap="square" lIns="73152" rIns="73152" tIns="36576" bIns="36576" anchor="ctr">
+            <a:spAutoFit/>
+          </a:bodyPr>
+          <a:lstStyle/>
+          <a:p>
+            <a:pPr algn="ctr"/>
+            <a:r>
+              <a:rPr sz="1100" b="1">
+                <a:solidFill>
+                  <a:srgbClr val="FFFFFF"/>
+                </a:solidFill>
+                <a:latin typeface="游ゴシック"/>
+              </a:rPr>
+              <a:t>運用機能</a:t>
+            </a:r>
+          </a:p>
+        </p:txBody>
+      </p:sp>
+      <p:sp>
+        <p:nvSpPr>
+          <p:cNvPr id="19" name="Pentagon 18"/>
+          <p:cNvSpPr/>
+          <p:nvPr/>
+        </p:nvSpPr>
+        <p:spPr>
+          <a:xfrm>
+            <a:off x="1417320" y="3840480"/>
+            <a:ext cx="4251960" cy="384048"/>
+          </a:xfrm>
+          <a:prstGeom prst="homePlate">
+            <a:avLst/>
+          </a:prstGeom>
+          <a:solidFill>
+            <a:srgbClr val="FFFFFF"/>
+          </a:solidFill>
+          <a:ln w="15875">
+            <a:solidFill>
+              <a:srgbClr val="4F81BD"/>
+            </a:solidFill>
+          </a:ln>
+        </p:spPr>
+        <p:style>
+          <a:lnRef idx="1">
+            <a:schemeClr val="accent1"/>
+          </a:lnRef>
+          <a:fillRef idx="3">
+            <a:schemeClr val="accent1"/>
+          </a:fillRef>
+          <a:effectRef idx="2">
+            <a:schemeClr val="accent1"/>
+          </a:effectRef>
+          <a:fontRef idx="minor">
+            <a:schemeClr val="lt1"/>
+          </a:fontRef>
+        </p:style>
+        <p:txBody>
+          <a:bodyPr rtlCol="0" anchor="ctr" lIns="137160" rIns="411480"/>
+          <a:lstStyle/>
+          <a:p>
+            <a:pPr algn="l"/>
+            <a:r>
+              <a:rPr sz="1100" b="1">
+                <a:solidFill>
+                  <a:srgbClr val="333333"/>
+                </a:solidFill>
+                <a:latin typeface="游ゴシック"/>
+              </a:rPr>
+              <a:t>不動産運用事業の機能強化</a:t>
+            </a:r>
+          </a:p>
+        </p:txBody>
+      </p:sp>
+      <p:sp>
+        <p:nvSpPr>
+          <p:cNvPr id="20" name="Rectangle 19"/>
+          <p:cNvSpPr/>
+          <p:nvPr/>
+        </p:nvSpPr>
+        <p:spPr>
+          <a:xfrm>
+            <a:off x="274320" y="4343400"/>
+            <a:ext cx="1097280" cy="384048"/>
+          </a:xfrm>
+          <a:prstGeom prst="rect">
+            <a:avLst/>
+          </a:prstGeom>
+          <a:solidFill>
+            <a:srgbClr val="4F81BD"/>
+          </a:solidFill>
+          <a:ln>
+            <a:noFill/>
+          </a:ln>
+          <a:effectLst/>
+        </p:spPr>
+        <p:style>
+          <a:lnRef idx="1">
+            <a:schemeClr val="accent1"/>
+          </a:lnRef>
+          <a:fillRef idx="3">
+            <a:schemeClr val="accent1"/>
+          </a:fillRef>
+          <a:effectRef idx="2">
+            <a:schemeClr val="accent1"/>
+          </a:effectRef>
+          <a:fontRef idx="minor">
+            <a:schemeClr val="lt1"/>
+          </a:fontRef>
+        </p:style>
+        <p:txBody>
+          <a:bodyPr rtlCol="0" anchor="ctr"/>
+          <a:lstStyle/>
+          <a:p>
+            <a:pPr algn="ctr"/>
+          </a:p>
+        </p:txBody>
+      </p:sp>
+      <p:sp>
+        <p:nvSpPr>
+          <p:cNvPr id="21" name="TextBox 20"/>
+          <p:cNvSpPr txBox="1"/>
+          <p:nvPr/>
+        </p:nvSpPr>
+        <p:spPr>
+          <a:xfrm>
+            <a:off x="274320" y="4343400"/>
+            <a:ext cx="1097280" cy="384048"/>
+          </a:xfrm>
+          <a:prstGeom prst="rect">
+            <a:avLst/>
+          </a:prstGeom>
+          <a:noFill/>
+        </p:spPr>
+        <p:txBody>
+          <a:bodyPr wrap="square" lIns="73152" rIns="73152" tIns="36576" bIns="36576" anchor="ctr">
+            <a:spAutoFit/>
+          </a:bodyPr>
+          <a:lstStyle/>
+          <a:p>
+            <a:pPr algn="ctr"/>
+            <a:r>
+              <a:rPr sz="1100" b="1">
+                <a:solidFill>
+                  <a:srgbClr val="FFFFFF"/>
+                </a:solidFill>
+                <a:latin typeface="游ゴシック"/>
+              </a:rPr>
+              <a:t>開発機能</a:t>
+            </a:r>
+          </a:p>
+        </p:txBody>
+      </p:sp>
+      <p:sp>
+        <p:nvSpPr>
+          <p:cNvPr id="22" name="Pentagon 21"/>
+          <p:cNvSpPr/>
+          <p:nvPr/>
+        </p:nvSpPr>
+        <p:spPr>
+          <a:xfrm>
+            <a:off x="1417320" y="4343400"/>
+            <a:ext cx="7452359" cy="384048"/>
+          </a:xfrm>
+          <a:prstGeom prst="homePlate">
+            <a:avLst/>
+          </a:prstGeom>
+          <a:solidFill>
+            <a:srgbClr val="FFFFFF"/>
+          </a:solidFill>
+          <a:ln w="15875">
+            <a:solidFill>
+              <a:srgbClr val="4F81BD"/>
+            </a:solidFill>
+          </a:ln>
+        </p:spPr>
+        <p:style>
+          <a:lnRef idx="1">
+            <a:schemeClr val="accent1"/>
+          </a:lnRef>
+          <a:fillRef idx="3">
+            <a:schemeClr val="accent1"/>
+          </a:fillRef>
+          <a:effectRef idx="2">
+            <a:schemeClr val="accent1"/>
+          </a:effectRef>
+          <a:fontRef idx="minor">
+            <a:schemeClr val="lt1"/>
+          </a:fontRef>
+        </p:style>
+        <p:txBody>
+          <a:bodyPr rtlCol="0" anchor="ctr" lIns="137160" rIns="411480"/>
+          <a:lstStyle/>
+          <a:p>
+            <a:pPr algn="l"/>
+            <a:r>
+              <a:rPr sz="1100" b="1">
+                <a:solidFill>
+                  <a:srgbClr val="333333"/>
+                </a:solidFill>
+                <a:latin typeface="游ゴシック"/>
+              </a:rPr>
+              <a:t>回転型不動産事業の機能強化</a:t>
+            </a:r>
+          </a:p>
+        </p:txBody>
+      </p:sp>
+      <p:sp>
+        <p:nvSpPr>
+          <p:cNvPr id="23" name="TextBox 22"/>
+          <p:cNvSpPr txBox="1"/>
+          <p:nvPr/>
+        </p:nvSpPr>
+        <p:spPr>
+          <a:xfrm>
+            <a:off x="274320" y="4846320"/>
+            <a:ext cx="8595360" cy="274320"/>
           </a:xfrm>
           <a:prstGeom prst="rect">
             <a:avLst/>
@@ -8974,201 +8625,13 @@
           <a:p>
             <a:pPr algn="l"/>
             <a:r>
-              <a:rPr sz="1100" b="1">
-                <a:solidFill>
-                  <a:srgbClr val="FFFFFF"/>
+              <a:rPr sz="800" b="0">
+                <a:solidFill>
+                  <a:srgbClr val="666A73"/>
                 </a:solidFill>
                 <a:latin typeface="游ゴシック"/>
               </a:rPr>
-              <a:t>④ 都市開発事業の確立</a:t>
-            </a:r>
-          </a:p>
-        </p:txBody>
-      </p:sp>
-      <p:sp>
-        <p:nvSpPr>
-          <p:cNvPr id="31" name="TextBox 30"/>
-          <p:cNvSpPr txBox="1"/>
-          <p:nvPr/>
-        </p:nvSpPr>
-        <p:spPr>
-          <a:xfrm>
-            <a:off x="7616951" y="1426464"/>
-            <a:ext cx="868680" cy="256032"/>
-          </a:xfrm>
-          <a:prstGeom prst="rect">
-            <a:avLst/>
-          </a:prstGeom>
-          <a:noFill/>
-        </p:spPr>
-        <p:txBody>
-          <a:bodyPr wrap="square" lIns="73152" rIns="73152" tIns="36576" bIns="36576" anchor="t">
-            <a:spAutoFit/>
-          </a:bodyPr>
-          <a:lstStyle/>
-          <a:p>
-            <a:pPr algn="r"/>
-            <a:r>
-              <a:rPr sz="900" b="1">
-                <a:solidFill>
-                  <a:srgbClr val="FFFFFF"/>
-                </a:solidFill>
-                <a:latin typeface="游ゴシック"/>
-              </a:rPr>
-              <a:t>累計 10/10</a:t>
-            </a:r>
-          </a:p>
-        </p:txBody>
-      </p:sp>
-      <p:sp>
-        <p:nvSpPr>
-          <p:cNvPr id="32" name="TextBox 31"/>
-          <p:cNvSpPr txBox="1"/>
-          <p:nvPr/>
-        </p:nvSpPr>
-        <p:spPr>
-          <a:xfrm>
-            <a:off x="6592824" y="1755648"/>
-            <a:ext cx="1911095" cy="2615183"/>
-          </a:xfrm>
-          <a:prstGeom prst="rect">
-            <a:avLst/>
-          </a:prstGeom>
-          <a:noFill/>
-        </p:spPr>
-        <p:txBody>
-          <a:bodyPr wrap="square">
-            <a:spAutoFit/>
-          </a:bodyPr>
-          <a:lstStyle/>
-          <a:p>
-            <a:pPr>
-              <a:spcBef>
-                <a:spcPts val="200"/>
-              </a:spcBef>
-            </a:pPr>
-            <a:r>
-              <a:rPr sz="800" b="1">
-                <a:solidFill>
-                  <a:srgbClr val="FFFFFF"/>
-                </a:solidFill>
-                <a:latin typeface="游ゴシック"/>
-              </a:rPr>
-              <a:t>[A] </a:t>
-            </a:r>
-            <a:r>
-              <a:rPr sz="900">
-                <a:solidFill>
-                  <a:srgbClr val="FFFFFF"/>
-                </a:solidFill>
-                <a:latin typeface="游ゴシック"/>
-              </a:rPr>
-              <a:t>高付加価値事業の収益化</a:t>
-            </a:r>
-          </a:p>
-        </p:txBody>
-      </p:sp>
-      <p:sp>
-        <p:nvSpPr>
-          <p:cNvPr id="33" name="TextBox 32"/>
-          <p:cNvSpPr txBox="1"/>
-          <p:nvPr/>
-        </p:nvSpPr>
-        <p:spPr>
-          <a:xfrm>
-            <a:off x="6592824" y="4389120"/>
-            <a:ext cx="1911095" cy="228600"/>
-          </a:xfrm>
-          <a:prstGeom prst="rect">
-            <a:avLst/>
-          </a:prstGeom>
-          <a:noFill/>
-        </p:spPr>
-        <p:txBody>
-          <a:bodyPr wrap="square" lIns="73152" rIns="73152" tIns="36576" bIns="36576" anchor="ctr">
-            <a:spAutoFit/>
-          </a:bodyPr>
-          <a:lstStyle/>
-          <a:p>
-            <a:pPr algn="l"/>
-            <a:r>
-              <a:rPr sz="900" b="1">
-                <a:solidFill>
-                  <a:srgbClr val="FFFFFF"/>
-                </a:solidFill>
-                <a:latin typeface="游ゴシック"/>
-              </a:rPr>
-              <a:t>+ 1機能 — 三軸の好循環が完成</a:t>
-            </a:r>
-          </a:p>
-        </p:txBody>
-      </p:sp>
-      <p:sp>
-        <p:nvSpPr>
-          <p:cNvPr id="34" name="TextBox 33"/>
-          <p:cNvSpPr txBox="1"/>
-          <p:nvPr/>
-        </p:nvSpPr>
-        <p:spPr>
-          <a:xfrm>
-            <a:off x="274320" y="868680"/>
-            <a:ext cx="5943600" cy="274320"/>
-          </a:xfrm>
-          <a:prstGeom prst="rect">
-            <a:avLst/>
-          </a:prstGeom>
-          <a:noFill/>
-        </p:spPr>
-        <p:txBody>
-          <a:bodyPr wrap="square" lIns="73152" rIns="73152" tIns="36576" bIns="36576" anchor="t">
-            <a:spAutoFit/>
-          </a:bodyPr>
-          <a:lstStyle/>
-          <a:p>
-            <a:pPr algn="l"/>
-            <a:r>
-              <a:rPr sz="1000" b="1">
-                <a:solidFill>
-                  <a:srgbClr val="0B2E5B"/>
-                </a:solidFill>
-                <a:latin typeface="游ゴシック"/>
-              </a:rPr>
-              <a:t>■ 各フェーズで機能を上乗せ（cumulative）し、最終フェーズで開発×運用×運営の好循環が完成</a:t>
-            </a:r>
-          </a:p>
-        </p:txBody>
-      </p:sp>
-      <p:sp>
-        <p:nvSpPr>
-          <p:cNvPr id="35" name="TextBox 34"/>
-          <p:cNvSpPr txBox="1"/>
-          <p:nvPr/>
-        </p:nvSpPr>
-        <p:spPr>
-          <a:xfrm>
-            <a:off x="274320" y="4846320"/>
-            <a:ext cx="8595360" cy="274320"/>
-          </a:xfrm>
-          <a:prstGeom prst="rect">
-            <a:avLst/>
-          </a:prstGeom>
-          <a:noFill/>
-        </p:spPr>
-        <p:txBody>
-          <a:bodyPr wrap="square" lIns="73152" rIns="73152" tIns="36576" bIns="36576" anchor="t">
-            <a:spAutoFit/>
-          </a:bodyPr>
-          <a:lstStyle/>
-          <a:p>
-            <a:pPr algn="l"/>
-            <a:r>
-              <a:rPr sz="800" b="0">
-                <a:solidFill>
-                  <a:srgbClr val="666A73"/>
-                </a:solidFill>
-                <a:latin typeface="游ゴシック"/>
-              </a:rPr>
-              <a:t>※ 階段の高さは各フェーズ終了時点の累計獲得機能数を視覚的に表現したものです（厳密な比例ではありません）。</a:t>
+              <a:t>※ 各フェーズで運用・開発の機能を順次強化し、最終的に回転型不動産事業を確立します。本ページの記述には将来見通しに関する情報を含みます。</a:t>
             </a:r>
           </a:p>
         </p:txBody>

</xml_diff>